<commit_message>
Speed up tab switches on Render with reused DB connections and Turbo-safe assets.
</commit_message>
<xml_diff>
--- a/Maksym_Shpak_Diploma_Presentation.pptx
+++ b/Maksym_Shpak_Diploma_Presentation.pptx
@@ -5413,7 +5413,7 @@
                 </a:solidFill>
                 <a:latin typeface="Calibri"/>
               </a:rPr>
-              <a:t>77 tests, four CI gates — </a:t>
+              <a:t>80 tests, four CI gates — </a:t>
             </a:r>
             <a:r>
               <a:rPr sz="1160" b="0" i="0">
@@ -7175,7 +7175,7 @@
                 </a:solidFill>
                 <a:latin typeface="Calibri"/>
               </a:rPr>
-              <a:t>Weighted grades, RBAC, EN/PL, 77 tests</a:t>
+              <a:t>Weighted grades, RBAC, EN/PL, 80 tests</a:t>
             </a:r>
           </a:p>
         </p:txBody>
@@ -18072,7 +18072,7 @@
                 </a:solidFill>
                 <a:latin typeface="Calibri"/>
               </a:rPr>
-              <a:t>308 strings, English ⇄ Polish, locale-aware dates. 77 automated tests and four CI gates (tests, migrations, deploy check, collectstatic) on every push.</a:t>
+              <a:t>308 strings, English ⇄ Polish, locale-aware dates. 80 automated tests and four CI gates (tests, migrations, deploy check, collectstatic) on every push.</a:t>
             </a:r>
           </a:p>
         </p:txBody>

</xml_diff>

<commit_message>
Point the live diploma URL at thesms.me.
</commit_message>
<xml_diff>
--- a/Maksym_Shpak_Diploma_Presentation.pptx
+++ b/Maksym_Shpak_Diploma_Presentation.pptx
@@ -3481,7 +3481,7 @@
                 <a:latin typeface="Calibri"/>
                 <a:hlinkClick r:id="rId4"/>
               </a:rPr>
-              <a:t>https://diploma-project-sms-management-system.onrender.com</a:t>
+              <a:t>https://thesms.me</a:t>
             </a:r>
           </a:p>
         </p:txBody>
@@ -4218,7 +4218,7 @@
                 <a:latin typeface="Calibri"/>
                 <a:hlinkClick r:id="rId4"/>
               </a:rPr>
-              <a:t>https://diploma-project-sms-management-system.onrender.com</a:t>
+              <a:t>https://thesms.me</a:t>
             </a:r>
           </a:p>
         </p:txBody>
@@ -6052,7 +6052,7 @@
                 <a:latin typeface="Calibri"/>
                 <a:hlinkClick r:id="rId2"/>
               </a:rPr>
-              <a:t>https://diploma-project-sms-management-system.onrender.com</a:t>
+              <a:t>https://thesms.me</a:t>
             </a:r>
           </a:p>
         </p:txBody>

</xml_diff>

<commit_message>
Rebuild the deck, and retire a PDF that contradicted it
</commit_message>
<xml_diff>
--- a/Maksym_Shpak_Diploma_Presentation.pptx
+++ b/Maksym_Shpak_Diploma_Presentation.pptx
@@ -5385,7 +5385,7 @@
                 </a:solidFill>
                 <a:latin typeface="Calibri"/>
               </a:rPr>
-              <a:t>308 strings, locale-aware dates and numbers</a:t>
+              <a:t>312 strings, locale-aware dates and numbers</a:t>
             </a:r>
           </a:p>
           <a:p>
@@ -5413,7 +5413,7 @@
                 </a:solidFill>
                 <a:latin typeface="Calibri"/>
               </a:rPr>
-              <a:t>80 tests, four CI gates — </a:t>
+              <a:t>96 tests, four CI gates — </a:t>
             </a:r>
             <a:r>
               <a:rPr sz="1160" b="0" i="0">
@@ -7175,7 +7175,7 @@
                 </a:solidFill>
                 <a:latin typeface="Calibri"/>
               </a:rPr>
-              <a:t>Weighted grades, RBAC, EN/PL, 80 tests</a:t>
+              <a:t>Weighted grades, RBAC, EN/PL, 96 tests</a:t>
             </a:r>
           </a:p>
         </p:txBody>
@@ -10480,7 +10480,7 @@
                           </a:solidFill>
                           <a:latin typeface="Calibri"/>
                         </a:rPr>
-                        <a:t>Native, 308 strings</a:t>
+                        <a:t>Native, 312 strings</a:t>
                       </a:r>
                     </a:p>
                   </a:txBody>
@@ -18072,7 +18072,7 @@
                 </a:solidFill>
                 <a:latin typeface="Calibri"/>
               </a:rPr>
-              <a:t>308 strings, English ⇄ Polish, locale-aware dates. 80 automated tests and four CI gates (tests, migrations, deploy check, collectstatic) on every push.</a:t>
+              <a:t>312 strings, English ⇄ Polish, locale-aware dates. 96 automated tests and four CI gates (tests, migrations, deploy check, collectstatic) on every push.</a:t>
             </a:r>
           </a:p>
         </p:txBody>

</xml_diff>

<commit_message>
Make every number on the slides match the code
</commit_message>
<xml_diff>
--- a/Maksym_Shpak_Diploma_Presentation.pptx
+++ b/Maksym_Shpak_Diploma_Presentation.pptx
@@ -4777,7 +4777,7 @@
                 </a:solidFill>
                 <a:latin typeface="Calibri"/>
               </a:rPr>
-              <a:t>enrollments</a:t>
+              <a:t>enrollment records</a:t>
             </a:r>
           </a:p>
         </p:txBody>
@@ -9068,7 +9068,7 @@
                 </a:solidFill>
                 <a:latin typeface="Calibri"/>
               </a:rPr>
-              <a:t>one auditable, role-aware platform now managing 25 students, 8 courses, 87 enrollments and 87 grades in production.</a:t>
+              <a:t>one auditable, role-aware platform now managing 25 students, 8 courses, 87 enrollment records — 51 of them active — and 87 grades in production.</a:t>
             </a:r>
           </a:p>
         </p:txBody>
@@ -11707,7 +11707,7 @@
                 </a:solidFill>
                 <a:latin typeface="Calibri"/>
               </a:rPr>
-              <a:t>Django Templates · 27 files</a:t>
+              <a:t>Django Templates · 30 files</a:t>
             </a:r>
           </a:p>
           <a:p>
@@ -11791,7 +11791,7 @@
                 </a:solidFill>
                 <a:latin typeface="Calibri"/>
               </a:rPr>
-              <a:t>Vanilla JavaScript ES6 · 413 lines</a:t>
+              <a:t>Vanilla JavaScript ES6 · 425 lines</a:t>
             </a:r>
           </a:p>
           <a:p>
@@ -18720,7 +18720,7 @@
                 </a:solidFill>
                 <a:latin typeface="Calibri"/>
               </a:rPr>
-              <a:t>down to 430 px</a:t>
+              <a:t>down to 375 px</a:t>
             </a:r>
           </a:p>
         </p:txBody>

</xml_diff>

<commit_message>
Drop the invented statistics from the problem slide
</commit_message>
<xml_diff>
--- a/Maksym_Shpak_Diploma_Presentation.pptx
+++ b/Maksym_Shpak_Diploma_Presentation.pptx
@@ -7889,7 +7889,7 @@
                 </a:solidFill>
                 <a:latin typeface="Calibri"/>
               </a:rPr>
-              <a:t>4–6 h</a:t>
+              <a:t>3 places</a:t>
             </a:r>
           </a:p>
           <a:p>
@@ -7908,8 +7908,8 @@
                 </a:solidFill>
                 <a:latin typeface="Calibri"/>
               </a:rPr>
-              <a:t>per week per teacher spent on
-manual record-keeping</a:t>
+              <a:t>spreadsheet, paper register
+and email thread</a:t>
             </a:r>
           </a:p>
         </p:txBody>
@@ -8042,7 +8042,7 @@
                 </a:solidFill>
                 <a:latin typeface="Calibri"/>
               </a:rPr>
-              <a:t>3 places</a:t>
+              <a:t>0</a:t>
             </a:r>
           </a:p>
           <a:p>
@@ -8061,8 +8061,8 @@
                 </a:solidFill>
                 <a:latin typeface="Calibri"/>
               </a:rPr>
-              <a:t>a single student record is
-split across today</a:t>
+              <a:t>audit trail of who entered
+or edited a grade</a:t>
             </a:r>
           </a:p>
         </p:txBody>
@@ -8195,7 +8195,7 @@
                 </a:solidFill>
                 <a:latin typeface="Calibri"/>
               </a:rPr>
-              <a:t>0</a:t>
+              <a:t>by hand</a:t>
             </a:r>
           </a:p>
           <a:p>
@@ -8214,8 +8214,8 @@
                 </a:solidFill>
                 <a:latin typeface="Calibri"/>
               </a:rPr>
-              <a:t>audit trail of who entered
-or edited a grade</a:t>
+              <a:t>every average and every
+attendance total</a:t>
             </a:r>
           </a:p>
         </p:txBody>

</xml_diff>

<commit_message>
Give bulk attendance marking the space it earns
</commit_message>
<xml_diff>
--- a/Maksym_Shpak_Diploma_Presentation.pptx
+++ b/Maksym_Shpak_Diploma_Presentation.pptx
@@ -18384,8 +18384,8 @@
         </p:nvSpPr>
         <p:spPr>
           <a:xfrm>
-            <a:off x="545459" y="1632204"/>
-            <a:ext cx="4636008" cy="2935223"/>
+            <a:off x="516635" y="1632204"/>
+            <a:ext cx="3246494" cy="2066778"/>
           </a:xfrm>
           <a:prstGeom prst="roundRect">
             <a:avLst>
@@ -18440,8 +18440,8 @@
         </p:blipFill>
         <p:spPr>
           <a:xfrm>
-            <a:off x="595751" y="1682496"/>
-            <a:ext cx="4535424" cy="2834639"/>
+            <a:off x="566928" y="1682496"/>
+            <a:ext cx="3145910" cy="1966194"/>
           </a:xfrm>
           <a:prstGeom prst="rect">
             <a:avLst/>
@@ -18456,8 +18456,8 @@
         </p:nvSpPr>
         <p:spPr>
           <a:xfrm>
-            <a:off x="595751" y="4645151"/>
-            <a:ext cx="4535424" cy="219456"/>
+            <a:off x="566928" y="3776706"/>
+            <a:ext cx="3145910" cy="219456"/>
           </a:xfrm>
           <a:prstGeom prst="rect">
             <a:avLst/>
@@ -18495,8 +18495,8 @@
         </p:nvSpPr>
         <p:spPr>
           <a:xfrm>
-            <a:off x="5391779" y="1632204"/>
-            <a:ext cx="4636008" cy="2935223"/>
+            <a:off x="3900290" y="1632204"/>
+            <a:ext cx="3246494" cy="2066778"/>
           </a:xfrm>
           <a:prstGeom prst="roundRect">
             <a:avLst>
@@ -18551,8 +18551,8 @@
         </p:blipFill>
         <p:spPr>
           <a:xfrm>
-            <a:off x="5442071" y="1682496"/>
-            <a:ext cx="4535424" cy="2834639"/>
+            <a:off x="3950582" y="1682496"/>
+            <a:ext cx="3145910" cy="1966194"/>
           </a:xfrm>
           <a:prstGeom prst="rect">
             <a:avLst/>
@@ -18567,8 +18567,8 @@
         </p:nvSpPr>
         <p:spPr>
           <a:xfrm>
-            <a:off x="5442071" y="4645151"/>
-            <a:ext cx="4535424" cy="219456"/>
+            <a:off x="3950582" y="3776706"/>
+            <a:ext cx="3145910" cy="219456"/>
           </a:xfrm>
           <a:prstGeom prst="rect">
             <a:avLst/>
@@ -18606,8 +18606,8 @@
         </p:nvSpPr>
         <p:spPr>
           <a:xfrm>
-            <a:off x="10238099" y="1632204"/>
-            <a:ext cx="1408411" cy="2935223"/>
+            <a:off x="7283945" y="1632204"/>
+            <a:ext cx="3246494" cy="2066778"/>
           </a:xfrm>
           <a:prstGeom prst="roundRect">
             <a:avLst>
@@ -18648,7 +18648,7 @@
       </p:sp>
       <p:pic>
         <p:nvPicPr>
-          <p:cNvPr id="16" name="Picture 15" descr="dashboard-mobile.png"/>
+          <p:cNvPr id="16" name="Picture 15" descr="attendance-mark-class.png"/>
           <p:cNvPicPr>
             <a:picLocks noChangeAspect="1"/>
           </p:cNvPicPr>
@@ -18662,8 +18662,8 @@
         </p:blipFill>
         <p:spPr>
           <a:xfrm>
-            <a:off x="10288391" y="1682496"/>
-            <a:ext cx="1307827" cy="2834639"/>
+            <a:off x="7334237" y="1682496"/>
+            <a:ext cx="3145910" cy="1966194"/>
           </a:xfrm>
           <a:prstGeom prst="rect">
             <a:avLst/>
@@ -18678,8 +18678,8 @@
         </p:nvSpPr>
         <p:spPr>
           <a:xfrm>
-            <a:off x="9876911" y="4645151"/>
-            <a:ext cx="2130787" cy="402336"/>
+            <a:off x="7334237" y="3776706"/>
+            <a:ext cx="3145910" cy="219456"/>
           </a:xfrm>
           <a:prstGeom prst="rect">
             <a:avLst/>
@@ -18692,6 +18692,117 @@
           </a:bodyPr>
           <a:lstStyle/>
           <a:p>
+            <a:pPr algn="l">
+              <a:spcAft>
+                <a:spcPts val="0"/>
+              </a:spcAft>
+            </a:pPr>
+            <a:r>
+              <a:rPr sz="1000" b="0" i="0" spc="50">
+                <a:solidFill>
+                  <a:srgbClr val="8C9AAF"/>
+                </a:solidFill>
+                <a:latin typeface="Calibri"/>
+              </a:rPr>
+              <a:t>Mark Class — a whole roster saved in one request</a:t>
+            </a:r>
+          </a:p>
+        </p:txBody>
+      </p:sp>
+      <p:sp>
+        <p:nvSpPr>
+          <p:cNvPr id="18" name="Rounded Rectangle 17"/>
+          <p:cNvSpPr/>
+          <p:nvPr/>
+        </p:nvSpPr>
+        <p:spPr>
+          <a:xfrm>
+            <a:off x="10667599" y="1632204"/>
+            <a:ext cx="1007733" cy="2066778"/>
+          </a:xfrm>
+          <a:prstGeom prst="roundRect">
+            <a:avLst>
+              <a:gd name="adj" fmla="val 5000"/>
+            </a:avLst>
+          </a:prstGeom>
+          <a:solidFill>
+            <a:srgbClr val="FFFFFF"/>
+          </a:solidFill>
+          <a:ln w="9525">
+            <a:solidFill>
+              <a:srgbClr val="E3E9F0"/>
+            </a:solidFill>
+          </a:ln>
+          <a:effectLst/>
+        </p:spPr>
+        <p:style>
+          <a:lnRef idx="1">
+            <a:schemeClr val="accent1"/>
+          </a:lnRef>
+          <a:fillRef idx="3">
+            <a:schemeClr val="accent1"/>
+          </a:fillRef>
+          <a:effectRef idx="2">
+            <a:schemeClr val="accent1"/>
+          </a:effectRef>
+          <a:fontRef idx="minor">
+            <a:schemeClr val="lt1"/>
+          </a:fontRef>
+        </p:style>
+        <p:txBody>
+          <a:bodyPr rtlCol="0" anchor="ctr" wrap="square" lIns="0" rIns="0" tIns="0" bIns="0"/>
+          <a:lstStyle/>
+          <a:p>
+            <a:pPr algn="ctr"/>
+          </a:p>
+        </p:txBody>
+      </p:sp>
+      <p:pic>
+        <p:nvPicPr>
+          <p:cNvPr id="19" name="Picture 18" descr="dashboard-mobile.png"/>
+          <p:cNvPicPr>
+            <a:picLocks noChangeAspect="1"/>
+          </p:cNvPicPr>
+          <p:nvPr/>
+        </p:nvPicPr>
+        <p:blipFill>
+          <a:blip r:embed="rId7"/>
+          <a:stretch>
+            <a:fillRect/>
+          </a:stretch>
+        </p:blipFill>
+        <p:spPr>
+          <a:xfrm>
+            <a:off x="10717891" y="1682496"/>
+            <a:ext cx="907149" cy="1966194"/>
+          </a:xfrm>
+          <a:prstGeom prst="rect">
+            <a:avLst/>
+          </a:prstGeom>
+        </p:spPr>
+      </p:pic>
+      <p:sp>
+        <p:nvSpPr>
+          <p:cNvPr id="20" name="TextBox 19"/>
+          <p:cNvSpPr txBox="1"/>
+          <p:nvPr/>
+        </p:nvSpPr>
+        <p:spPr>
+          <a:xfrm>
+            <a:off x="10306411" y="3776706"/>
+            <a:ext cx="1730109" cy="402336"/>
+          </a:xfrm>
+          <a:prstGeom prst="rect">
+            <a:avLst/>
+          </a:prstGeom>
+          <a:noFill/>
+        </p:spPr>
+        <p:txBody>
+          <a:bodyPr wrap="square" lIns="0" rIns="0" tIns="0" bIns="0" anchor="t">
+            <a:spAutoFit/>
+          </a:bodyPr>
+          <a:lstStyle/>
+          <a:p>
             <a:pPr algn="ctr">
               <a:spcAft>
                 <a:spcPts val="200"/>
@@ -18727,7 +18838,7 @@
       </p:sp>
       <p:sp>
         <p:nvSpPr>
-          <p:cNvPr id="18" name="Rounded Rectangle 17"/>
+          <p:cNvPr id="21" name="Rounded Rectangle 20"/>
           <p:cNvSpPr/>
           <p:nvPr/>
         </p:nvSpPr>
@@ -18773,7 +18884,7 @@
       </p:sp>
       <p:sp>
         <p:nvSpPr>
-          <p:cNvPr id="19" name="TextBox 18"/>
+          <p:cNvPr id="22" name="TextBox 21"/>
           <p:cNvSpPr txBox="1"/>
           <p:nvPr/>
         </p:nvSpPr>

</xml_diff>

<commit_message>
Say PostgreSQL 18, which is what the database actually runs
</commit_message>
<xml_diff>
--- a/Maksym_Shpak_Diploma_Presentation.pptx
+++ b/Maksym_Shpak_Diploma_Presentation.pptx
@@ -6796,7 +6796,7 @@
                 </a:solidFill>
                 <a:latin typeface="Calibri"/>
               </a:rPr>
-              <a:t>Django 6, Python 3.12, PostgreSQL 16</a:t>
+              <a:t>Django 6, Python 3.12, PostgreSQL 18</a:t>
             </a:r>
           </a:p>
         </p:txBody>
@@ -11367,7 +11367,7 @@
                 </a:solidFill>
                 <a:latin typeface="Calibri"/>
               </a:rPr>
-              <a:t>PostgreSQL 16 (Neon)</a:t>
+              <a:t>PostgreSQL 18 (Neon)</a:t>
             </a:r>
           </a:p>
           <a:p>
@@ -13468,7 +13468,7 @@
                 </a:solidFill>
                 <a:latin typeface="Calibri"/>
               </a:rPr>
-              <a:t>PostgreSQL 16</a:t>
+              <a:t>PostgreSQL 18</a:t>
             </a:r>
           </a:p>
           <a:p>

</xml_diff>

<commit_message>
Point the defence tiles at the live dashboard KPIs.
</commit_message>
<xml_diff>
--- a/Maksym_Shpak_Diploma_Presentation.pptx
+++ b/Maksym_Shpak_Diploma_Presentation.pptx
@@ -4758,7 +4758,7 @@
                 </a:solidFill>
                 <a:latin typeface="Calibri"/>
               </a:rPr>
-              <a:t>87</a:t>
+              <a:t>51</a:t>
             </a:r>
           </a:p>
           <a:p>
@@ -4777,7 +4777,7 @@
                 </a:solidFill>
                 <a:latin typeface="Calibri"/>
               </a:rPr>
-              <a:t>enrollment records</a:t>
+              <a:t>enrollments</a:t>
             </a:r>
           </a:p>
         </p:txBody>
@@ -4910,7 +4910,7 @@
                 </a:solidFill>
                 <a:latin typeface="Calibri"/>
               </a:rPr>
-              <a:t>87</a:t>
+              <a:t>3.70</a:t>
             </a:r>
           </a:p>
           <a:p>
@@ -4929,7 +4929,7 @@
                 </a:solidFill>
                 <a:latin typeface="Calibri"/>
               </a:rPr>
-              <a:t>grades</a:t>
+              <a:t>avg. grade</a:t>
             </a:r>
           </a:p>
         </p:txBody>
@@ -5348,7 +5348,7 @@
                 </a:solidFill>
                 <a:latin typeface="Calibri"/>
               </a:rPr>
-              <a:t>admins and teachers see strictly their own data</a:t>
+              <a:t>teachers see their courses; admins see the institution</a:t>
             </a:r>
           </a:p>
           <a:p>
@@ -5413,7 +5413,7 @@
                 </a:solidFill>
                 <a:latin typeface="Calibri"/>
               </a:rPr>
-              <a:t>96 tests, four CI gates — </a:t>
+              <a:t>111 tests + live smoke — </a:t>
             </a:r>
             <a:r>
               <a:rPr sz="1160" b="0" i="0">
@@ -5422,7 +5422,7 @@
                 </a:solidFill>
                 <a:latin typeface="Calibri"/>
               </a:rPr>
-              <a:t>green on every push, then build.sh deploys</a:t>
+              <a:t>suite locally; Actions hits the deployed site</a:t>
             </a:r>
           </a:p>
         </p:txBody>
@@ -7175,7 +7175,7 @@
                 </a:solidFill>
                 <a:latin typeface="Calibri"/>
               </a:rPr>
-              <a:t>Weighted grades, RBAC, EN/PL, 96 tests</a:t>
+              <a:t>Weighted grades, RBAC, EN/PL, 111 tests</a:t>
             </a:r>
           </a:p>
         </p:txBody>
@@ -9068,7 +9068,7 @@
                 </a:solidFill>
                 <a:latin typeface="Calibri"/>
               </a:rPr>
-              <a:t>one auditable, role-aware platform now managing 25 students, 8 courses, 87 enrollment records — 51 of them active — and 87 grades in production.</a:t>
+              <a:t>25 students, 8 courses, 51 active enrolments and a 3.70 mean mark — the same four KPI tiles as the live dashboard.</a:t>
             </a:r>
           </a:p>
         </p:txBody>
@@ -18072,7 +18072,7 @@
                 </a:solidFill>
                 <a:latin typeface="Calibri"/>
               </a:rPr>
-              <a:t>312 strings, English ⇄ Polish, locale-aware dates. 96 automated tests and four CI gates (tests, migrations, deploy check, collectstatic) on every push.</a:t>
+              <a:t>312 strings, English ⇄ Polish, locale-aware dates. 111 automated tests; GitHub Actions runs a live smoke job against thesms.me.</a:t>
             </a:r>
           </a:p>
         </p:txBody>

</xml_diff>